<commit_message>
Bài giảng điện tử Toán 11 tuần 1–8 (Bài 1–9, BTCC I–III, Ôn tập GK1) + 8 trang GeoGebra + 3 video mở đầu; Toán 12 Chương I gắn video mở đầu
Co-Authored-By: Claude Opus 5.5 <noreply@anthropic.com>
</commit_message>
<xml_diff>
--- a/mon/toan/slide/lop12/BaiGiangDienTu_TOAN12_Bai3_DuongTiemCan_T10-13.pptx
+++ b/mon/toan/slide/lop12/BaiGiangDienTu_TOAN12_Bai3_DuongTiemCan_T10-13.pptx
@@ -3280,7 +3280,7 @@
           <a:lstStyle/>
           <a:p>
             <a:r>
-              <a:t>5'. HS dự đoán: khối lượng giảm dần, tiến về 0; đồ thị tiến sát trục hoành. Giải ở Vận dụng 1 cùng tiết.</a:t>
+              <a:t>Chiếu video mở đầu (ảnh thật, lồng tiếng, phụ đề – không nói đáp án), HS quét QR xem lại. 5'. HS dự đoán: khối lượng giảm dần, tiến về 0; đồ thị tiến sát trục hoành. Giải ở Vận dụng 1 cùng tiết.</a:t>
             </a:r>
           </a:p>
         </p:txBody>
@@ -48933,7 +48933,7 @@
             <p:spPr>
               <a:xfrm>
                 <a:off x="548640" y="1417320"/>
-                <a:ext cx="6766560" cy="4389120"/>
+                <a:ext cx="6583680" cy="3840480"/>
               </a:xfrm>
               <a:prstGeom prst="rect">
                 <a:avLst/>
@@ -49129,7 +49129,7 @@
             <p:spPr>
               <a:xfrm>
                 <a:off x="548640" y="1417320"/>
-                <a:ext cx="6766560" cy="4389120"/>
+                <a:ext cx="6583680" cy="3840480"/>
               </a:xfrm>
               <a:prstGeom prst="rect">
                 <a:avLst/>
@@ -49238,40 +49238,119 @@
           </p:sp>
         </mc:Fallback>
       </mc:AlternateContent>
+      <p:sp>
+        <p:nvSpPr>
+          <p:cNvPr id="8" name="Rounded Rectangle 7">
+            <a:hlinkClick r:id="rId3"/>
+          </p:cNvPr>
+          <p:cNvSpPr/>
+          <p:nvPr/>
+        </p:nvSpPr>
+        <p:spPr>
+          <a:xfrm>
+            <a:off x="548640" y="5349240"/>
+            <a:ext cx="3931920" cy="640080"/>
+          </a:xfrm>
+          <a:prstGeom prst="roundRect">
+            <a:avLst/>
+          </a:prstGeom>
+          <a:solidFill>
+            <a:srgbClr val="D97706"/>
+          </a:solidFill>
+          <a:ln>
+            <a:noFill/>
+          </a:ln>
+          <a:effectLst/>
+        </p:spPr>
+        <p:style>
+          <a:lnRef idx="1">
+            <a:schemeClr val="accent1"/>
+          </a:lnRef>
+          <a:fillRef idx="3">
+            <a:schemeClr val="accent1"/>
+          </a:fillRef>
+          <a:effectRef idx="2">
+            <a:schemeClr val="accent1"/>
+          </a:effectRef>
+          <a:fontRef idx="minor">
+            <a:schemeClr val="lt1"/>
+          </a:fontRef>
+        </p:style>
+        <p:txBody>
+          <a:bodyPr rtlCol="0" anchor="ctr" wrap="square"/>
+          <a:lstStyle/>
+          <a:p>
+            <a:pPr algn="ctr"/>
+            <a:r>
+              <a:rPr sz="2000" b="1">
+                <a:solidFill>
+                  <a:srgbClr val="FFFFFF"/>
+                </a:solidFill>
+                <a:latin typeface="Calibri"/>
+              </a:rPr>
+              <a:t>▶  VIDEO MỞ ĐẦU</a:t>
+            </a:r>
+          </a:p>
+        </p:txBody>
+      </p:sp>
       <p:pic>
         <p:nvPicPr>
-          <p:cNvPr id="8" name="Picture 7" descr="b3_h118.png"/>
+          <p:cNvPr id="9" name="Picture 8" descr="qr_video.png"/>
           <p:cNvPicPr>
             <a:picLocks noChangeAspect="1"/>
           </p:cNvPicPr>
           <p:nvPr/>
         </p:nvPicPr>
         <p:blipFill>
-          <a:blip r:embed="rId3"/>
+          <a:blip r:embed="rId4"/>
           <a:stretch>
             <a:fillRect/>
           </a:stretch>
         </p:blipFill>
         <p:spPr>
           <a:xfrm>
-            <a:off x="7498079" y="2313296"/>
-            <a:ext cx="4206240" cy="2322848"/>
+            <a:off x="4663440" y="5074920"/>
+            <a:ext cx="1188720" cy="1188720"/>
           </a:xfrm>
           <a:prstGeom prst="rect">
             <a:avLst/>
           </a:prstGeom>
         </p:spPr>
       </p:pic>
-      <p:sp>
-        <p:nvSpPr>
-          <p:cNvPr id="9" name="TextBox 8"/>
+      <p:pic>
+        <p:nvPicPr>
+          <p:cNvPr id="10" name="Picture 9" descr="b3_h118.png"/>
+          <p:cNvPicPr>
+            <a:picLocks noChangeAspect="1"/>
+          </p:cNvPicPr>
+          <p:nvPr/>
+        </p:nvPicPr>
+        <p:blipFill>
+          <a:blip r:embed="rId5"/>
+          <a:stretch>
+            <a:fillRect/>
+          </a:stretch>
+        </p:blipFill>
+        <p:spPr>
+          <a:xfrm>
+            <a:off x="7315200" y="2262799"/>
+            <a:ext cx="4389120" cy="2423842"/>
+          </a:xfrm>
+          <a:prstGeom prst="rect">
+            <a:avLst/>
+          </a:prstGeom>
+        </p:spPr>
+      </p:pic>
+      <p:sp>
+        <p:nvSpPr>
+          <p:cNvPr id="11" name="TextBox 10"/>
           <p:cNvSpPr txBox="1"/>
           <p:nvPr/>
         </p:nvSpPr>
         <p:spPr>
           <a:xfrm>
-            <a:off x="7498079" y="5413248"/>
-            <a:ext cx="4206240" cy="365760"/>
+            <a:off x="7315200" y="5504688"/>
+            <a:ext cx="4389120" cy="365760"/>
           </a:xfrm>
           <a:prstGeom prst="rect">
             <a:avLst/>

</xml_diff>